<commit_message>
feat: 於第01頁封面與第28頁離席提醒新增官方網站專屬 QR Code (https://clive520.github.io/parent-meeting/)
</commit_message>
<xml_diff>
--- a/六年一班班親會_全套簡報.pptx
+++ b/六年一班班親會_全套簡報.pptx
@@ -3419,6 +3419,181 @@
           </a:p>
         </p:txBody>
       </p:sp>
+      <p:sp>
+        <p:nvSpPr>
+          <p:cNvPr id="11" name="TextBox 10"/>
+          <p:cNvSpPr txBox="1"/>
+          <p:nvPr/>
+        </p:nvSpPr>
+        <p:spPr>
+          <a:xfrm>
+            <a:off x="9277349" y="1549400"/>
+            <a:ext cx="1129283" cy="209549"/>
+          </a:xfrm>
+          <a:prstGeom prst="rect">
+            <a:avLst/>
+          </a:prstGeom>
+          <a:noFill/>
+        </p:spPr>
+        <p:txBody>
+          <a:bodyPr wrap="none" lIns="0" rIns="0" tIns="0" bIns="0">
+            <a:spAutoFit/>
+          </a:bodyPr>
+          <a:lstStyle/>
+          <a:p>
+            <a:r>
+              <a:rPr sz="1650" b="1">
+                <a:solidFill>
+                  <a:srgbClr val="FFFFFF"/>
+                </a:solidFill>
+                <a:latin typeface="Microsoft JhengHei"/>
+                <a:ea typeface="Microsoft JhengHei"/>
+              </a:rPr>
+              <a:t>班親專屬網站</a:t>
+            </a:r>
+          </a:p>
+        </p:txBody>
+      </p:sp>
+      <p:sp>
+        <p:nvSpPr>
+          <p:cNvPr id="12" name="TextBox 11"/>
+          <p:cNvSpPr txBox="1"/>
+          <p:nvPr/>
+        </p:nvSpPr>
+        <p:spPr>
+          <a:xfrm>
+            <a:off x="9175749" y="1828800"/>
+            <a:ext cx="2011171" cy="304800"/>
+          </a:xfrm>
+          <a:prstGeom prst="rect">
+            <a:avLst/>
+          </a:prstGeom>
+          <a:noFill/>
+        </p:spPr>
+        <p:txBody>
+          <a:bodyPr wrap="none" lIns="0" rIns="0" tIns="0" bIns="0">
+            <a:spAutoFit/>
+          </a:bodyPr>
+          <a:lstStyle/>
+          <a:p>
+            <a:r>
+              <a:rPr sz="2400" b="1">
+                <a:solidFill>
+                  <a:srgbClr val="2C5E8A"/>
+                </a:solidFill>
+                <a:latin typeface="Microsoft JhengHei"/>
+                <a:ea typeface="Microsoft JhengHei"/>
+              </a:rPr>
+              <a:t>掃描開啟班親手冊</a:t>
+            </a:r>
+          </a:p>
+        </p:txBody>
+      </p:sp>
+      <p:sp>
+        <p:nvSpPr>
+          <p:cNvPr id="13" name="TextBox 12"/>
+          <p:cNvSpPr txBox="1"/>
+          <p:nvPr/>
+        </p:nvSpPr>
+        <p:spPr>
+          <a:xfrm>
+            <a:off x="9175749" y="2114550"/>
+            <a:ext cx="2039619" cy="190500"/>
+          </a:xfrm>
+          <a:prstGeom prst="rect">
+            <a:avLst/>
+          </a:prstGeom>
+          <a:noFill/>
+        </p:spPr>
+        <p:txBody>
+          <a:bodyPr wrap="none" lIns="0" rIns="0" tIns="0" bIns="0">
+            <a:spAutoFit/>
+          </a:bodyPr>
+          <a:lstStyle/>
+          <a:p>
+            <a:r>
+              <a:rPr sz="1500" b="0">
+                <a:solidFill>
+                  <a:srgbClr val="718096"/>
+                </a:solidFill>
+                <a:latin typeface="Microsoft JhengHei"/>
+                <a:ea typeface="Microsoft JhengHei"/>
+              </a:rPr>
+              <a:t>現場免抄筆記・線上同步瀏覽</a:t>
+            </a:r>
+          </a:p>
+        </p:txBody>
+      </p:sp>
+      <p:sp>
+        <p:nvSpPr>
+          <p:cNvPr id="14" name="TextBox 13"/>
+          <p:cNvSpPr txBox="1"/>
+          <p:nvPr/>
+        </p:nvSpPr>
+        <p:spPr>
+          <a:xfrm>
+            <a:off x="9207499" y="3987799"/>
+            <a:ext cx="2847340" cy="152400"/>
+          </a:xfrm>
+          <a:prstGeom prst="rect">
+            <a:avLst/>
+          </a:prstGeom>
+          <a:noFill/>
+        </p:spPr>
+        <p:txBody>
+          <a:bodyPr wrap="none" lIns="0" rIns="0" tIns="0" bIns="0">
+            <a:spAutoFit/>
+          </a:bodyPr>
+          <a:lstStyle/>
+          <a:p>
+            <a:r>
+              <a:rPr sz="1200" b="0">
+                <a:solidFill>
+                  <a:srgbClr val="718096"/>
+                </a:solidFill>
+                <a:latin typeface="Microsoft JhengHei"/>
+                <a:ea typeface="Microsoft JhengHei"/>
+              </a:rPr>
+              <a:t>網址：clive520.github.io/parent-meeting</a:t>
+            </a:r>
+          </a:p>
+        </p:txBody>
+      </p:sp>
+      <p:sp>
+        <p:nvSpPr>
+          <p:cNvPr id="15" name="TextBox 14"/>
+          <p:cNvSpPr txBox="1"/>
+          <p:nvPr/>
+        </p:nvSpPr>
+        <p:spPr>
+          <a:xfrm>
+            <a:off x="9372599" y="4216400"/>
+            <a:ext cx="1726691" cy="171450"/>
+          </a:xfrm>
+          <a:prstGeom prst="rect">
+            <a:avLst/>
+          </a:prstGeom>
+          <a:noFill/>
+        </p:spPr>
+        <p:txBody>
+          <a:bodyPr wrap="none" lIns="0" rIns="0" tIns="0" bIns="0">
+            <a:spAutoFit/>
+          </a:bodyPr>
+          <a:lstStyle/>
+          <a:p>
+            <a:r>
+              <a:rPr sz="1350" b="1">
+                <a:solidFill>
+                  <a:srgbClr val="2C5E8A"/>
+                </a:solidFill>
+                <a:latin typeface="Microsoft JhengHei"/>
+                <a:ea typeface="Microsoft JhengHei"/>
+              </a:rPr>
+              <a:t>免排隊零等待・全彩隨身看</a:t>
+            </a:r>
+          </a:p>
+        </p:txBody>
+      </p:sp>
     </p:spTree>
   </p:cSld>
   <p:clrMapOvr>
@@ -17694,7 +17869,7 @@
                 <a:latin typeface="Microsoft JhengHei"/>
                 <a:ea typeface="Microsoft JhengHei"/>
               </a:rPr>
-              <a:t>感謝各位家長熱情參與・離席前請協助確認完成以下三項核心要事</a:t>
+              <a:t>感謝各位家長熱情參與・離席前請協助確認完成以下三大核心要事</a:t>
             </a:r>
           </a:p>
         </p:txBody>
@@ -17707,22 +17882,22 @@
         </p:nvSpPr>
         <p:spPr>
           <a:xfrm>
-            <a:off x="850899" y="1892299"/>
-            <a:ext cx="1484883" cy="247649"/>
-          </a:xfrm>
-          <a:prstGeom prst="rect">
-            <a:avLst/>
-          </a:prstGeom>
-          <a:noFill/>
-        </p:spPr>
-        <p:txBody>
-          <a:bodyPr wrap="none" lIns="0" rIns="0" tIns="0" bIns="0">
-            <a:spAutoFit/>
-          </a:bodyPr>
-          <a:lstStyle/>
-          <a:p>
-            <a:r>
-              <a:rPr sz="1950" b="1">
+            <a:off x="787399" y="1860550"/>
+            <a:ext cx="1385315" cy="228600"/>
+          </a:xfrm>
+          <a:prstGeom prst="rect">
+            <a:avLst/>
+          </a:prstGeom>
+          <a:noFill/>
+        </p:spPr>
+        <p:txBody>
+          <a:bodyPr wrap="none" lIns="0" rIns="0" tIns="0" bIns="0">
+            <a:spAutoFit/>
+          </a:bodyPr>
+          <a:lstStyle/>
+          <a:p>
+            <a:r>
+              <a:rPr sz="1800" b="1">
                 <a:solidFill>
                   <a:srgbClr val="FFFFFF"/>
                 </a:solidFill>
@@ -17742,22 +17917,22 @@
         </p:nvSpPr>
         <p:spPr>
           <a:xfrm>
-            <a:off x="698499" y="2273300"/>
-            <a:ext cx="1812035" cy="361950"/>
-          </a:xfrm>
-          <a:prstGeom prst="rect">
-            <a:avLst/>
-          </a:prstGeom>
-          <a:noFill/>
-        </p:spPr>
-        <p:txBody>
-          <a:bodyPr wrap="none" lIns="0" rIns="0" tIns="0" bIns="0">
-            <a:spAutoFit/>
-          </a:bodyPr>
-          <a:lstStyle/>
-          <a:p>
-            <a:r>
-              <a:rPr sz="2850" b="1">
+            <a:off x="634999" y="2209800"/>
+            <a:ext cx="1641347" cy="323849"/>
+          </a:xfrm>
+          <a:prstGeom prst="rect">
+            <a:avLst/>
+          </a:prstGeom>
+          <a:noFill/>
+        </p:spPr>
+        <p:txBody>
+          <a:bodyPr wrap="none" lIns="0" rIns="0" tIns="0" bIns="0">
+            <a:spAutoFit/>
+          </a:bodyPr>
+          <a:lstStyle/>
+          <a:p>
+            <a:r>
+              <a:rPr sz="2550" b="1">
                 <a:solidFill>
                   <a:srgbClr val="2C5E8A"/>
                 </a:solidFill>
@@ -17777,22 +17952,22 @@
         </p:nvSpPr>
         <p:spPr>
           <a:xfrm>
-            <a:off x="787399" y="2679700"/>
-            <a:ext cx="1470659" cy="190500"/>
-          </a:xfrm>
-          <a:prstGeom prst="rect">
-            <a:avLst/>
-          </a:prstGeom>
-          <a:noFill/>
-        </p:spPr>
-        <p:txBody>
-          <a:bodyPr wrap="none" lIns="0" rIns="0" tIns="0" bIns="0">
-            <a:spAutoFit/>
-          </a:bodyPr>
-          <a:lstStyle/>
-          <a:p>
-            <a:r>
-              <a:rPr sz="1500" b="1">
+            <a:off x="711199" y="2616200"/>
+            <a:ext cx="1406651" cy="180975"/>
+          </a:xfrm>
+          <a:prstGeom prst="rect">
+            <a:avLst/>
+          </a:prstGeom>
+          <a:noFill/>
+        </p:spPr>
+        <p:txBody>
+          <a:bodyPr wrap="none" lIns="0" rIns="0" tIns="0" bIns="0">
+            <a:spAutoFit/>
+          </a:bodyPr>
+          <a:lstStyle/>
+          <a:p>
+            <a:r>
+              <a:rPr sz="1425" b="1">
                 <a:solidFill>
                   <a:srgbClr val="2C5E8A"/>
                 </a:solidFill>
@@ -17812,22 +17987,22 @@
         </p:nvSpPr>
         <p:spPr>
           <a:xfrm>
-            <a:off x="920749" y="3067050"/>
-            <a:ext cx="1854707" cy="247649"/>
-          </a:xfrm>
-          <a:prstGeom prst="rect">
-            <a:avLst/>
-          </a:prstGeom>
-          <a:noFill/>
-        </p:spPr>
-        <p:txBody>
-          <a:bodyPr wrap="none" lIns="0" rIns="0" tIns="0" bIns="0">
-            <a:spAutoFit/>
-          </a:bodyPr>
-          <a:lstStyle/>
-          <a:p>
-            <a:r>
-              <a:rPr sz="1950" b="1">
+            <a:off x="793749" y="3003549"/>
+            <a:ext cx="1726691" cy="228600"/>
+          </a:xfrm>
+          <a:prstGeom prst="rect">
+            <a:avLst/>
+          </a:prstGeom>
+          <a:noFill/>
+        </p:spPr>
+        <p:txBody>
+          <a:bodyPr wrap="none" lIns="0" rIns="0" tIns="0" bIns="0">
+            <a:spAutoFit/>
+          </a:bodyPr>
+          <a:lstStyle/>
+          <a:p>
+            <a:r>
+              <a:rPr sz="1800" b="1">
                 <a:solidFill>
                   <a:srgbClr val="2D3748"/>
                 </a:solidFill>
@@ -17847,22 +18022,22 @@
         </p:nvSpPr>
         <p:spPr>
           <a:xfrm>
-            <a:off x="920749" y="3511550"/>
-            <a:ext cx="1669795" cy="247649"/>
-          </a:xfrm>
-          <a:prstGeom prst="rect">
-            <a:avLst/>
-          </a:prstGeom>
-          <a:noFill/>
-        </p:spPr>
-        <p:txBody>
-          <a:bodyPr wrap="none" lIns="0" rIns="0" tIns="0" bIns="0">
-            <a:spAutoFit/>
-          </a:bodyPr>
-          <a:lstStyle/>
-          <a:p>
-            <a:r>
-              <a:rPr sz="1950" b="1">
+            <a:off x="793749" y="3460749"/>
+            <a:ext cx="1556003" cy="228600"/>
+          </a:xfrm>
+          <a:prstGeom prst="rect">
+            <a:avLst/>
+          </a:prstGeom>
+          <a:noFill/>
+        </p:spPr>
+        <p:txBody>
+          <a:bodyPr wrap="none" lIns="0" rIns="0" tIns="0" bIns="0">
+            <a:spAutoFit/>
+          </a:bodyPr>
+          <a:lstStyle/>
+          <a:p>
+            <a:r>
+              <a:rPr sz="1800" b="1">
                 <a:solidFill>
                   <a:srgbClr val="2D3748"/>
                 </a:solidFill>
@@ -17882,29 +18057,29 @@
         </p:nvSpPr>
         <p:spPr>
           <a:xfrm>
-            <a:off x="920749" y="3956049"/>
-            <a:ext cx="2039619" cy="247649"/>
-          </a:xfrm>
-          <a:prstGeom prst="rect">
-            <a:avLst/>
-          </a:prstGeom>
-          <a:noFill/>
-        </p:spPr>
-        <p:txBody>
-          <a:bodyPr wrap="none" lIns="0" rIns="0" tIns="0" bIns="0">
-            <a:spAutoFit/>
-          </a:bodyPr>
-          <a:lstStyle/>
-          <a:p>
-            <a:r>
-              <a:rPr sz="1950" b="1">
-                <a:solidFill>
-                  <a:srgbClr val="2D3748"/>
-                </a:solidFill>
-                <a:latin typeface="Microsoft JhengHei"/>
-                <a:ea typeface="Microsoft JhengHei"/>
-              </a:rPr>
-              <a:t>領取各處室書面通知單</a:t>
+            <a:off x="793749" y="3917950"/>
+            <a:ext cx="1556003" cy="228600"/>
+          </a:xfrm>
+          <a:prstGeom prst="rect">
+            <a:avLst/>
+          </a:prstGeom>
+          <a:noFill/>
+        </p:spPr>
+        <p:txBody>
+          <a:bodyPr wrap="none" lIns="0" rIns="0" tIns="0" bIns="0">
+            <a:spAutoFit/>
+          </a:bodyPr>
+          <a:lstStyle/>
+          <a:p>
+            <a:r>
+              <a:rPr sz="1800" b="1">
+                <a:solidFill>
+                  <a:srgbClr val="2D3748"/>
+                </a:solidFill>
+                <a:latin typeface="Microsoft JhengHei"/>
+                <a:ea typeface="Microsoft JhengHei"/>
+              </a:rPr>
+              <a:t>領取各處室通知單</a:t>
             </a:r>
           </a:p>
         </p:txBody>
@@ -17917,29 +18092,29 @@
         </p:nvSpPr>
         <p:spPr>
           <a:xfrm>
-            <a:off x="920749" y="4400550"/>
-            <a:ext cx="2039619" cy="247649"/>
-          </a:xfrm>
-          <a:prstGeom prst="rect">
-            <a:avLst/>
-          </a:prstGeom>
-          <a:noFill/>
-        </p:spPr>
-        <p:txBody>
-          <a:bodyPr wrap="none" lIns="0" rIns="0" tIns="0" bIns="0">
-            <a:spAutoFit/>
-          </a:bodyPr>
-          <a:lstStyle/>
-          <a:p>
-            <a:r>
-              <a:rPr sz="1950" b="1">
-                <a:solidFill>
-                  <a:srgbClr val="2D3748"/>
-                </a:solidFill>
-                <a:latin typeface="Microsoft JhengHei"/>
-                <a:ea typeface="Microsoft JhengHei"/>
-              </a:rPr>
-              <a:t>確保親師通訊管道暢通</a:t>
+            <a:off x="793749" y="4375150"/>
+            <a:ext cx="1556003" cy="228600"/>
+          </a:xfrm>
+          <a:prstGeom prst="rect">
+            <a:avLst/>
+          </a:prstGeom>
+          <a:noFill/>
+        </p:spPr>
+        <p:txBody>
+          <a:bodyPr wrap="none" lIns="0" rIns="0" tIns="0" bIns="0">
+            <a:spAutoFit/>
+          </a:bodyPr>
+          <a:lstStyle/>
+          <a:p>
+            <a:r>
+              <a:rPr sz="1800" b="1">
+                <a:solidFill>
+                  <a:srgbClr val="2D3748"/>
+                </a:solidFill>
+                <a:latin typeface="Microsoft JhengHei"/>
+                <a:ea typeface="Microsoft JhengHei"/>
+              </a:rPr>
+              <a:t>確保通訊管道暢通</a:t>
             </a:r>
           </a:p>
         </p:txBody>
@@ -17952,22 +18127,22 @@
         </p:nvSpPr>
         <p:spPr>
           <a:xfrm>
-            <a:off x="4724399" y="1892299"/>
-            <a:ext cx="1484883" cy="247649"/>
-          </a:xfrm>
-          <a:prstGeom prst="rect">
-            <a:avLst/>
-          </a:prstGeom>
-          <a:noFill/>
-        </p:spPr>
-        <p:txBody>
-          <a:bodyPr wrap="none" lIns="0" rIns="0" tIns="0" bIns="0">
-            <a:spAutoFit/>
-          </a:bodyPr>
-          <a:lstStyle/>
-          <a:p>
-            <a:r>
-              <a:rPr sz="1950" b="1">
+            <a:off x="3613149" y="1860550"/>
+            <a:ext cx="1385315" cy="228600"/>
+          </a:xfrm>
+          <a:prstGeom prst="rect">
+            <a:avLst/>
+          </a:prstGeom>
+          <a:noFill/>
+        </p:spPr>
+        <p:txBody>
+          <a:bodyPr wrap="none" lIns="0" rIns="0" tIns="0" bIns="0">
+            <a:spAutoFit/>
+          </a:bodyPr>
+          <a:lstStyle/>
+          <a:p>
+            <a:r>
+              <a:rPr sz="1800" b="1">
                 <a:solidFill>
                   <a:srgbClr val="FFFFFF"/>
                 </a:solidFill>
@@ -17987,22 +18162,22 @@
         </p:nvSpPr>
         <p:spPr>
           <a:xfrm>
-            <a:off x="4571999" y="2273300"/>
-            <a:ext cx="2082291" cy="361950"/>
-          </a:xfrm>
-          <a:prstGeom prst="rect">
-            <a:avLst/>
-          </a:prstGeom>
-          <a:noFill/>
-        </p:spPr>
-        <p:txBody>
-          <a:bodyPr wrap="none" lIns="0" rIns="0" tIns="0" bIns="0">
-            <a:spAutoFit/>
-          </a:bodyPr>
-          <a:lstStyle/>
-          <a:p>
-            <a:r>
-              <a:rPr sz="2850" b="1">
+            <a:off x="3460749" y="2209800"/>
+            <a:ext cx="1883155" cy="323849"/>
+          </a:xfrm>
+          <a:prstGeom prst="rect">
+            <a:avLst/>
+          </a:prstGeom>
+          <a:noFill/>
+        </p:spPr>
+        <p:txBody>
+          <a:bodyPr wrap="none" lIns="0" rIns="0" tIns="0" bIns="0">
+            <a:spAutoFit/>
+          </a:bodyPr>
+          <a:lstStyle/>
+          <a:p>
+            <a:r>
+              <a:rPr sz="2550" b="1">
                 <a:solidFill>
                   <a:srgbClr val="E88D67"/>
                 </a:solidFill>
@@ -18022,22 +18197,22 @@
         </p:nvSpPr>
         <p:spPr>
           <a:xfrm>
-            <a:off x="4660899" y="2679700"/>
-            <a:ext cx="1328419" cy="190500"/>
-          </a:xfrm>
-          <a:prstGeom prst="rect">
-            <a:avLst/>
-          </a:prstGeom>
-          <a:noFill/>
-        </p:spPr>
-        <p:txBody>
-          <a:bodyPr wrap="none" lIns="0" rIns="0" tIns="0" bIns="0">
-            <a:spAutoFit/>
-          </a:bodyPr>
-          <a:lstStyle/>
-          <a:p>
-            <a:r>
-              <a:rPr sz="1500" b="1">
+            <a:off x="3536949" y="2616200"/>
+            <a:ext cx="1271523" cy="180975"/>
+          </a:xfrm>
+          <a:prstGeom prst="rect">
+            <a:avLst/>
+          </a:prstGeom>
+          <a:noFill/>
+        </p:spPr>
+        <p:txBody>
+          <a:bodyPr wrap="none" lIns="0" rIns="0" tIns="0" bIns="0">
+            <a:spAutoFit/>
+          </a:bodyPr>
+          <a:lstStyle/>
+          <a:p>
+            <a:r>
+              <a:rPr sz="1425" b="1">
                 <a:solidFill>
                   <a:srgbClr val="E88D67"/>
                 </a:solidFill>
@@ -18057,29 +18232,29 @@
         </p:nvSpPr>
         <p:spPr>
           <a:xfrm>
-            <a:off x="4794249" y="3067050"/>
-            <a:ext cx="2779267" cy="247649"/>
-          </a:xfrm>
-          <a:prstGeom prst="rect">
-            <a:avLst/>
-          </a:prstGeom>
-          <a:noFill/>
-        </p:spPr>
-        <p:txBody>
-          <a:bodyPr wrap="none" lIns="0" rIns="0" tIns="0" bIns="0">
-            <a:spAutoFit/>
-          </a:bodyPr>
-          <a:lstStyle/>
-          <a:p>
-            <a:r>
-              <a:rPr sz="1950" b="1">
-                <a:solidFill>
-                  <a:srgbClr val="2D3748"/>
-                </a:solidFill>
-                <a:latin typeface="Microsoft JhengHei"/>
-                <a:ea typeface="Microsoft JhengHei"/>
-              </a:rPr>
-              <a:t>推選確認 601「班親會長」</a:t>
+            <a:off x="3619499" y="3003549"/>
+            <a:ext cx="2238755" cy="228600"/>
+          </a:xfrm>
+          <a:prstGeom prst="rect">
+            <a:avLst/>
+          </a:prstGeom>
+          <a:noFill/>
+        </p:spPr>
+        <p:txBody>
+          <a:bodyPr wrap="none" lIns="0" rIns="0" tIns="0" bIns="0">
+            <a:spAutoFit/>
+          </a:bodyPr>
+          <a:lstStyle/>
+          <a:p>
+            <a:r>
+              <a:rPr sz="1800" b="1">
+                <a:solidFill>
+                  <a:srgbClr val="2D3748"/>
+                </a:solidFill>
+                <a:latin typeface="Microsoft JhengHei"/>
+                <a:ea typeface="Microsoft JhengHei"/>
+              </a:rPr>
+              <a:t>推選確認 601「會長」</a:t>
             </a:r>
           </a:p>
         </p:txBody>
@@ -18092,29 +18267,29 @@
         </p:nvSpPr>
         <p:spPr>
           <a:xfrm>
-            <a:off x="4794249" y="3511550"/>
-            <a:ext cx="2409443" cy="247649"/>
-          </a:xfrm>
-          <a:prstGeom prst="rect">
-            <a:avLst/>
-          </a:prstGeom>
-          <a:noFill/>
-        </p:spPr>
-        <p:txBody>
-          <a:bodyPr wrap="none" lIns="0" rIns="0" tIns="0" bIns="0">
-            <a:spAutoFit/>
-          </a:bodyPr>
-          <a:lstStyle/>
-          <a:p>
-            <a:r>
-              <a:rPr sz="1950" b="1">
-                <a:solidFill>
-                  <a:srgbClr val="2D3748"/>
-                </a:solidFill>
-                <a:latin typeface="Microsoft JhengHei"/>
-                <a:ea typeface="Microsoft JhengHei"/>
-              </a:rPr>
-              <a:t>推選確認班級「總務幹部」</a:t>
+            <a:off x="3619499" y="3460749"/>
+            <a:ext cx="1897379" cy="228600"/>
+          </a:xfrm>
+          <a:prstGeom prst="rect">
+            <a:avLst/>
+          </a:prstGeom>
+          <a:noFill/>
+        </p:spPr>
+        <p:txBody>
+          <a:bodyPr wrap="none" lIns="0" rIns="0" tIns="0" bIns="0">
+            <a:spAutoFit/>
+          </a:bodyPr>
+          <a:lstStyle/>
+          <a:p>
+            <a:r>
+              <a:rPr sz="1800" b="1">
+                <a:solidFill>
+                  <a:srgbClr val="2D3748"/>
+                </a:solidFill>
+                <a:latin typeface="Microsoft JhengHei"/>
+                <a:ea typeface="Microsoft JhengHei"/>
+              </a:rPr>
+              <a:t>推選確認「總務幹部」</a:t>
             </a:r>
           </a:p>
         </p:txBody>
@@ -18127,29 +18302,29 @@
         </p:nvSpPr>
         <p:spPr>
           <a:xfrm>
-            <a:off x="4794249" y="3956049"/>
-            <a:ext cx="2594355" cy="247649"/>
-          </a:xfrm>
-          <a:prstGeom prst="rect">
-            <a:avLst/>
-          </a:prstGeom>
-          <a:noFill/>
-        </p:spPr>
-        <p:txBody>
-          <a:bodyPr wrap="none" lIns="0" rIns="0" tIns="0" bIns="0">
-            <a:spAutoFit/>
-          </a:bodyPr>
-          <a:lstStyle/>
-          <a:p>
-            <a:r>
-              <a:rPr sz="1950" b="1">
-                <a:solidFill>
-                  <a:srgbClr val="2D3748"/>
-                </a:solidFill>
-                <a:latin typeface="Microsoft JhengHei"/>
-                <a:ea typeface="Microsoft JhengHei"/>
-              </a:rPr>
-              <a:t>共同把關畢業專案與各項經費</a:t>
+            <a:off x="3619499" y="3917950"/>
+            <a:ext cx="1897379" cy="228600"/>
+          </a:xfrm>
+          <a:prstGeom prst="rect">
+            <a:avLst/>
+          </a:prstGeom>
+          <a:noFill/>
+        </p:spPr>
+        <p:txBody>
+          <a:bodyPr wrap="none" lIns="0" rIns="0" tIns="0" bIns="0">
+            <a:spAutoFit/>
+          </a:bodyPr>
+          <a:lstStyle/>
+          <a:p>
+            <a:r>
+              <a:rPr sz="1800" b="1">
+                <a:solidFill>
+                  <a:srgbClr val="2D3748"/>
+                </a:solidFill>
+                <a:latin typeface="Microsoft JhengHei"/>
+                <a:ea typeface="Microsoft JhengHei"/>
+              </a:rPr>
+              <a:t>共同把關畢業各項經費</a:t>
             </a:r>
           </a:p>
         </p:txBody>
@@ -18162,29 +18337,29 @@
         </p:nvSpPr>
         <p:spPr>
           <a:xfrm>
-            <a:off x="4794249" y="4400550"/>
-            <a:ext cx="2224531" cy="247649"/>
-          </a:xfrm>
-          <a:prstGeom prst="rect">
-            <a:avLst/>
-          </a:prstGeom>
-          <a:noFill/>
-        </p:spPr>
-        <p:txBody>
-          <a:bodyPr wrap="none" lIns="0" rIns="0" tIns="0" bIns="0">
-            <a:spAutoFit/>
-          </a:bodyPr>
-          <a:lstStyle/>
-          <a:p>
-            <a:r>
-              <a:rPr sz="1950" b="1">
-                <a:solidFill>
-                  <a:srgbClr val="2D3748"/>
-                </a:solidFill>
-                <a:latin typeface="Microsoft JhengHei"/>
-                <a:ea typeface="Microsoft JhengHei"/>
-              </a:rPr>
-              <a:t>親師攜手做孩子最強後援</a:t>
+            <a:off x="3619499" y="4375150"/>
+            <a:ext cx="1726691" cy="228600"/>
+          </a:xfrm>
+          <a:prstGeom prst="rect">
+            <a:avLst/>
+          </a:prstGeom>
+          <a:noFill/>
+        </p:spPr>
+        <p:txBody>
+          <a:bodyPr wrap="none" lIns="0" rIns="0" tIns="0" bIns="0">
+            <a:spAutoFit/>
+          </a:bodyPr>
+          <a:lstStyle/>
+          <a:p>
+            <a:r>
+              <a:rPr sz="1800" b="1">
+                <a:solidFill>
+                  <a:srgbClr val="2D3748"/>
+                </a:solidFill>
+                <a:latin typeface="Microsoft JhengHei"/>
+                <a:ea typeface="Microsoft JhengHei"/>
+              </a:rPr>
+              <a:t>親師攜手做最強後援</a:t>
             </a:r>
           </a:p>
         </p:txBody>
@@ -18197,22 +18372,22 @@
         </p:nvSpPr>
         <p:spPr>
           <a:xfrm>
-            <a:off x="8597899" y="1892299"/>
-            <a:ext cx="1484883" cy="247649"/>
-          </a:xfrm>
-          <a:prstGeom prst="rect">
-            <a:avLst/>
-          </a:prstGeom>
-          <a:noFill/>
-        </p:spPr>
-        <p:txBody>
-          <a:bodyPr wrap="none" lIns="0" rIns="0" tIns="0" bIns="0">
-            <a:spAutoFit/>
-          </a:bodyPr>
-          <a:lstStyle/>
-          <a:p>
-            <a:r>
-              <a:rPr sz="1950" b="1">
+            <a:off x="6438899" y="1860550"/>
+            <a:ext cx="1385315" cy="228600"/>
+          </a:xfrm>
+          <a:prstGeom prst="rect">
+            <a:avLst/>
+          </a:prstGeom>
+          <a:noFill/>
+        </p:spPr>
+        <p:txBody>
+          <a:bodyPr wrap="none" lIns="0" rIns="0" tIns="0" bIns="0">
+            <a:spAutoFit/>
+          </a:bodyPr>
+          <a:lstStyle/>
+          <a:p>
+            <a:r>
+              <a:rPr sz="1800" b="1">
                 <a:solidFill>
                   <a:srgbClr val="FFFFFF"/>
                 </a:solidFill>
@@ -18232,29 +18407,29 @@
         </p:nvSpPr>
         <p:spPr>
           <a:xfrm>
-            <a:off x="8445499" y="2273300"/>
-            <a:ext cx="2352547" cy="361950"/>
-          </a:xfrm>
-          <a:prstGeom prst="rect">
-            <a:avLst/>
-          </a:prstGeom>
-          <a:noFill/>
-        </p:spPr>
-        <p:txBody>
-          <a:bodyPr wrap="none" lIns="0" rIns="0" tIns="0" bIns="0">
-            <a:spAutoFit/>
-          </a:bodyPr>
-          <a:lstStyle/>
-          <a:p>
-            <a:r>
-              <a:rPr sz="2850" b="1">
+            <a:off x="6286499" y="2209800"/>
+            <a:ext cx="1641347" cy="323849"/>
+          </a:xfrm>
+          <a:prstGeom prst="rect">
+            <a:avLst/>
+          </a:prstGeom>
+          <a:noFill/>
+        </p:spPr>
+        <p:txBody>
+          <a:bodyPr wrap="none" lIns="0" rIns="0" tIns="0" bIns="0">
+            <a:spAutoFit/>
+          </a:bodyPr>
+          <a:lstStyle/>
+          <a:p>
+            <a:r>
+              <a:rPr sz="2550" b="1">
                 <a:solidFill>
                   <a:srgbClr val="58A47E"/>
                 </a:solidFill>
                 <a:latin typeface="Microsoft JhengHei"/>
                 <a:ea typeface="Microsoft JhengHei"/>
               </a:rPr>
-              <a:t>愛心志工意願登記</a:t>
+              <a:t>愛心志工意願</a:t>
             </a:r>
           </a:p>
         </p:txBody>
@@ -18267,22 +18442,22 @@
         </p:nvSpPr>
         <p:spPr>
           <a:xfrm>
-            <a:off x="8534399" y="2679700"/>
-            <a:ext cx="1328419" cy="190500"/>
-          </a:xfrm>
-          <a:prstGeom prst="rect">
-            <a:avLst/>
-          </a:prstGeom>
-          <a:noFill/>
-        </p:spPr>
-        <p:txBody>
-          <a:bodyPr wrap="none" lIns="0" rIns="0" tIns="0" bIns="0">
-            <a:spAutoFit/>
-          </a:bodyPr>
-          <a:lstStyle/>
-          <a:p>
-            <a:r>
-              <a:rPr sz="1500" b="1">
+            <a:off x="6362699" y="2616200"/>
+            <a:ext cx="1271523" cy="180975"/>
+          </a:xfrm>
+          <a:prstGeom prst="rect">
+            <a:avLst/>
+          </a:prstGeom>
+          <a:noFill/>
+        </p:spPr>
+        <p:txBody>
+          <a:bodyPr wrap="none" lIns="0" rIns="0" tIns="0" bIns="0">
+            <a:spAutoFit/>
+          </a:bodyPr>
+          <a:lstStyle/>
+          <a:p>
+            <a:r>
+              <a:rPr sz="1425" b="1">
                 <a:solidFill>
                   <a:srgbClr val="58A47E"/>
                 </a:solidFill>
@@ -18302,22 +18477,22 @@
         </p:nvSpPr>
         <p:spPr>
           <a:xfrm>
-            <a:off x="8667749" y="3067050"/>
-            <a:ext cx="2224531" cy="247649"/>
-          </a:xfrm>
-          <a:prstGeom prst="rect">
-            <a:avLst/>
-          </a:prstGeom>
-          <a:noFill/>
-        </p:spPr>
-        <p:txBody>
-          <a:bodyPr wrap="none" lIns="0" rIns="0" tIns="0" bIns="0">
-            <a:spAutoFit/>
-          </a:bodyPr>
-          <a:lstStyle/>
-          <a:p>
-            <a:r>
-              <a:rPr sz="1950" b="1">
+            <a:off x="6445249" y="3003549"/>
+            <a:ext cx="2068067" cy="228600"/>
+          </a:xfrm>
+          <a:prstGeom prst="rect">
+            <a:avLst/>
+          </a:prstGeom>
+          <a:noFill/>
+        </p:spPr>
+        <p:txBody>
+          <a:bodyPr wrap="none" lIns="0" rIns="0" tIns="0" bIns="0">
+            <a:spAutoFit/>
+          </a:bodyPr>
+          <a:lstStyle/>
+          <a:p>
+            <a:r>
+              <a:rPr sz="1800" b="1">
                 <a:solidFill>
                   <a:srgbClr val="2D3748"/>
                 </a:solidFill>
@@ -18337,29 +18512,29 @@
         </p:nvSpPr>
         <p:spPr>
           <a:xfrm>
-            <a:off x="8667749" y="3511550"/>
-            <a:ext cx="2409443" cy="247649"/>
-          </a:xfrm>
-          <a:prstGeom prst="rect">
-            <a:avLst/>
-          </a:prstGeom>
-          <a:noFill/>
-        </p:spPr>
-        <p:txBody>
-          <a:bodyPr wrap="none" lIns="0" rIns="0" tIns="0" bIns="0">
-            <a:spAutoFit/>
-          </a:bodyPr>
-          <a:lstStyle/>
-          <a:p>
-            <a:r>
-              <a:rPr sz="1950" b="1">
-                <a:solidFill>
-                  <a:srgbClr val="2D3748"/>
-                </a:solidFill>
-                <a:latin typeface="Microsoft JhengHei"/>
-                <a:ea typeface="Microsoft JhengHei"/>
-              </a:rPr>
-              <a:t>圖書組：晨間書籍借還推廣</a:t>
+            <a:off x="6445249" y="3460749"/>
+            <a:ext cx="1897379" cy="228600"/>
+          </a:xfrm>
+          <a:prstGeom prst="rect">
+            <a:avLst/>
+          </a:prstGeom>
+          <a:noFill/>
+        </p:spPr>
+        <p:txBody>
+          <a:bodyPr wrap="none" lIns="0" rIns="0" tIns="0" bIns="0">
+            <a:spAutoFit/>
+          </a:bodyPr>
+          <a:lstStyle/>
+          <a:p>
+            <a:r>
+              <a:rPr sz="1800" b="1">
+                <a:solidFill>
+                  <a:srgbClr val="2D3748"/>
+                </a:solidFill>
+                <a:latin typeface="Microsoft JhengHei"/>
+                <a:ea typeface="Microsoft JhengHei"/>
+              </a:rPr>
+              <a:t>圖書組：晨間書籍借還</a:t>
             </a:r>
           </a:p>
         </p:txBody>
@@ -18372,22 +18547,22 @@
         </p:nvSpPr>
         <p:spPr>
           <a:xfrm>
-            <a:off x="8667749" y="3956049"/>
-            <a:ext cx="2039619" cy="247649"/>
-          </a:xfrm>
-          <a:prstGeom prst="rect">
-            <a:avLst/>
-          </a:prstGeom>
-          <a:noFill/>
-        </p:spPr>
-        <p:txBody>
-          <a:bodyPr wrap="none" lIns="0" rIns="0" tIns="0" bIns="0">
-            <a:spAutoFit/>
-          </a:bodyPr>
-          <a:lstStyle/>
-          <a:p>
-            <a:r>
-              <a:rPr sz="1950" b="1">
+            <a:off x="6445249" y="3917950"/>
+            <a:ext cx="1897379" cy="228600"/>
+          </a:xfrm>
+          <a:prstGeom prst="rect">
+            <a:avLst/>
+          </a:prstGeom>
+          <a:noFill/>
+        </p:spPr>
+        <p:txBody>
+          <a:bodyPr wrap="none" lIns="0" rIns="0" tIns="0" bIns="0">
+            <a:spAutoFit/>
+          </a:bodyPr>
+          <a:lstStyle/>
+          <a:p>
+            <a:r>
+              <a:rPr sz="1800" b="1">
                 <a:solidFill>
                   <a:srgbClr val="2D3748"/>
                 </a:solidFill>
@@ -18407,29 +18582,29 @@
         </p:nvSpPr>
         <p:spPr>
           <a:xfrm>
-            <a:off x="8667749" y="4400550"/>
-            <a:ext cx="2409443" cy="247649"/>
-          </a:xfrm>
-          <a:prstGeom prst="rect">
-            <a:avLst/>
-          </a:prstGeom>
-          <a:noFill/>
-        </p:spPr>
-        <p:txBody>
-          <a:bodyPr wrap="none" lIns="0" rIns="0" tIns="0" bIns="0">
-            <a:spAutoFit/>
-          </a:bodyPr>
-          <a:lstStyle/>
-          <a:p>
-            <a:r>
-              <a:rPr sz="1950" b="1">
-                <a:solidFill>
-                  <a:srgbClr val="2D3748"/>
-                </a:solidFill>
-                <a:latin typeface="Microsoft JhengHei"/>
-                <a:ea typeface="Microsoft JhengHei"/>
-              </a:rPr>
-              <a:t>或填妥紙本回條由孩子帶來</a:t>
+            <a:off x="6445249" y="4375150"/>
+            <a:ext cx="1897379" cy="228600"/>
+          </a:xfrm>
+          <a:prstGeom prst="rect">
+            <a:avLst/>
+          </a:prstGeom>
+          <a:noFill/>
+        </p:spPr>
+        <p:txBody>
+          <a:bodyPr wrap="none" lIns="0" rIns="0" tIns="0" bIns="0">
+            <a:spAutoFit/>
+          </a:bodyPr>
+          <a:lstStyle/>
+          <a:p>
+            <a:r>
+              <a:rPr sz="1800" b="1">
+                <a:solidFill>
+                  <a:srgbClr val="2D3748"/>
+                </a:solidFill>
+                <a:latin typeface="Microsoft JhengHei"/>
+                <a:ea typeface="Microsoft JhengHei"/>
+              </a:rPr>
+              <a:t>或填妥回條由孩子帶來</a:t>
             </a:r>
           </a:p>
         </p:txBody>
@@ -18437,6 +18612,181 @@
       <p:sp>
         <p:nvSpPr>
           <p:cNvPr id="28" name="TextBox 27"/>
+          <p:cNvSpPr txBox="1"/>
+          <p:nvPr/>
+        </p:nvSpPr>
+        <p:spPr>
+          <a:xfrm>
+            <a:off x="9264649" y="1860550"/>
+            <a:ext cx="1214627" cy="228600"/>
+          </a:xfrm>
+          <a:prstGeom prst="rect">
+            <a:avLst/>
+          </a:prstGeom>
+          <a:noFill/>
+        </p:spPr>
+        <p:txBody>
+          <a:bodyPr wrap="none" lIns="0" rIns="0" tIns="0" bIns="0">
+            <a:spAutoFit/>
+          </a:bodyPr>
+          <a:lstStyle/>
+          <a:p>
+            <a:r>
+              <a:rPr sz="1800" b="1">
+                <a:solidFill>
+                  <a:srgbClr val="FFFFFF"/>
+                </a:solidFill>
+                <a:latin typeface="Microsoft JhengHei"/>
+                <a:ea typeface="Microsoft JhengHei"/>
+              </a:rPr>
+              <a:t>班親專屬網站</a:t>
+            </a:r>
+          </a:p>
+        </p:txBody>
+      </p:sp>
+      <p:sp>
+        <p:nvSpPr>
+          <p:cNvPr id="29" name="TextBox 28"/>
+          <p:cNvSpPr txBox="1"/>
+          <p:nvPr/>
+        </p:nvSpPr>
+        <p:spPr>
+          <a:xfrm>
+            <a:off x="9112249" y="2209800"/>
+            <a:ext cx="2011171" cy="304800"/>
+          </a:xfrm>
+          <a:prstGeom prst="rect">
+            <a:avLst/>
+          </a:prstGeom>
+          <a:noFill/>
+        </p:spPr>
+        <p:txBody>
+          <a:bodyPr wrap="none" lIns="0" rIns="0" tIns="0" bIns="0">
+            <a:spAutoFit/>
+          </a:bodyPr>
+          <a:lstStyle/>
+          <a:p>
+            <a:r>
+              <a:rPr sz="2400" b="1">
+                <a:solidFill>
+                  <a:srgbClr val="2C5E8A"/>
+                </a:solidFill>
+                <a:latin typeface="Microsoft JhengHei"/>
+                <a:ea typeface="Microsoft JhengHei"/>
+              </a:rPr>
+              <a:t>掃描帶走電子手冊</a:t>
+            </a:r>
+          </a:p>
+        </p:txBody>
+      </p:sp>
+      <p:sp>
+        <p:nvSpPr>
+          <p:cNvPr id="30" name="TextBox 29"/>
+          <p:cNvSpPr txBox="1"/>
+          <p:nvPr/>
+        </p:nvSpPr>
+        <p:spPr>
+          <a:xfrm>
+            <a:off x="9143999" y="4273550"/>
+            <a:ext cx="1911603" cy="209549"/>
+          </a:xfrm>
+          <a:prstGeom prst="rect">
+            <a:avLst/>
+          </a:prstGeom>
+          <a:noFill/>
+        </p:spPr>
+        <p:txBody>
+          <a:bodyPr wrap="none" lIns="0" rIns="0" tIns="0" bIns="0">
+            <a:spAutoFit/>
+          </a:bodyPr>
+          <a:lstStyle/>
+          <a:p>
+            <a:r>
+              <a:rPr sz="1650" b="1">
+                <a:solidFill>
+                  <a:srgbClr val="2D3748"/>
+                </a:solidFill>
+                <a:latin typeface="Microsoft JhengHei"/>
+                <a:ea typeface="Microsoft JhengHei"/>
+              </a:rPr>
+              <a:t>手機隨身查閱・轉傳家人</a:t>
+            </a:r>
+          </a:p>
+        </p:txBody>
+      </p:sp>
+      <p:sp>
+        <p:nvSpPr>
+          <p:cNvPr id="31" name="TextBox 30"/>
+          <p:cNvSpPr txBox="1"/>
+          <p:nvPr/>
+        </p:nvSpPr>
+        <p:spPr>
+          <a:xfrm>
+            <a:off x="9143999" y="4527550"/>
+            <a:ext cx="2352547" cy="180975"/>
+          </a:xfrm>
+          <a:prstGeom prst="rect">
+            <a:avLst/>
+          </a:prstGeom>
+          <a:noFill/>
+        </p:spPr>
+        <p:txBody>
+          <a:bodyPr wrap="none" lIns="0" rIns="0" tIns="0" bIns="0">
+            <a:spAutoFit/>
+          </a:bodyPr>
+          <a:lstStyle/>
+          <a:p>
+            <a:r>
+              <a:rPr sz="1425" b="0">
+                <a:solidFill>
+                  <a:srgbClr val="718096"/>
+                </a:solidFill>
+                <a:latin typeface="Microsoft JhengHei"/>
+                <a:ea typeface="Microsoft JhengHei"/>
+              </a:rPr>
+              <a:t>完整簡報 × 評量 × 畢冊報價</a:t>
+            </a:r>
+          </a:p>
+        </p:txBody>
+      </p:sp>
+      <p:sp>
+        <p:nvSpPr>
+          <p:cNvPr id="32" name="TextBox 31"/>
+          <p:cNvSpPr txBox="1"/>
+          <p:nvPr/>
+        </p:nvSpPr>
+        <p:spPr>
+          <a:xfrm>
+            <a:off x="9143999" y="4781549"/>
+            <a:ext cx="2910840" cy="152400"/>
+          </a:xfrm>
+          <a:prstGeom prst="rect">
+            <a:avLst/>
+          </a:prstGeom>
+          <a:noFill/>
+        </p:spPr>
+        <p:txBody>
+          <a:bodyPr wrap="none" lIns="0" rIns="0" tIns="0" bIns="0">
+            <a:spAutoFit/>
+          </a:bodyPr>
+          <a:lstStyle/>
+          <a:p>
+            <a:r>
+              <a:rPr sz="1200" b="0">
+                <a:solidFill>
+                  <a:srgbClr val="2C5E8A"/>
+                </a:solidFill>
+                <a:latin typeface="Microsoft JhengHei"/>
+                <a:ea typeface="Microsoft JhengHei"/>
+              </a:rPr>
+              <a:t>clive520.github.io/parent-meeting</a:t>
+            </a:r>
+          </a:p>
+        </p:txBody>
+      </p:sp>
+      <p:sp>
+        <p:nvSpPr>
+          <p:cNvPr id="33" name="TextBox 32"/>
           <p:cNvSpPr txBox="1"/>
           <p:nvPr/>
         </p:nvSpPr>
@@ -18471,7 +18821,7 @@
       </p:sp>
       <p:sp>
         <p:nvSpPr>
-          <p:cNvPr id="29" name="TextBox 28"/>
+          <p:cNvPr id="34" name="TextBox 33"/>
           <p:cNvSpPr txBox="1"/>
           <p:nvPr/>
         </p:nvSpPr>

</xml_diff>